<commit_message>
docs: plan full thesis continuation and structural validation
</commit_message>
<xml_diff>
--- a/docs/thesis/presentation/PRESENTACION_TESIS_DATA_MOVEMENT_ACTUALIZADA.pptx
+++ b/docs/thesis/presentation/PRESENTACION_TESIS_DATA_MOVEMENT_ACTUALIZADA.pptx
@@ -1139,7 +1139,7 @@
           <a:lstStyle xmlns:a="http://schemas.openxmlformats.org/drawingml/2006/main"/>
           <a:p xmlns:a="http://schemas.openxmlformats.org/drawingml/2006/main">
             <a:r>
-              <a:t>Checkpoint 2026-10-03: Gate I cerrado localmente en 3f44f30 con suite e integraciones PASS. I14 pendiente. Gate V tiene matriz y oráculos preparados; la campaña requiere workers activos y una decisión posterior. No se iniciaron workflows nuevos.</a:t>
+              <a:t>Gate I cerró en 3f44f30. Matriz propuesta: 117 runs base y 12 de sensibilidad estructural, total 129 workflows nuevos. El generador histórico limita balanced-local a 3 etapas o 4 ramas; el bloque estructural usa same-w1. I14 debe usar Analyzer v1. No se ejecutaron workflows nuevos.</a:t>
             </a:r>
           </a:p>
         </p:txBody>
@@ -13501,7 +13501,7 @@
                 <a:ea typeface="Aptos"/>
                 <a:cs typeface="Aptos"/>
               </a:rPr>
-              <a:t>Gate I cerró en 3f44f30. La campaña de 117 casos requiere workers activos, runner I14 y decisión de ejecución.</a:t>
+              <a:t>Gate I cerró en 3f44f30. Se proponen 129 workflows: 117 base y 12 estructurales. Requieren workers activos y decisión de ejecución.</a:t>
             </a:r>
             <a:endParaRPr sz="1120"/>
           </a:p>

</xml_diff>